<commit_message>
minor updates to one slide
</commit_message>
<xml_diff>
--- a/PowerPoints/06 - Syntax Analysis.pptx
+++ b/PowerPoints/06 - Syntax Analysis.pptx
@@ -13207,7 +13207,13 @@
               <a:rPr lang="en-US" sz="1800" dirty="0" err="1">
                 <a:latin typeface="Consolas" panose="020B0609020204030204" pitchFamily="49" charset="0"/>
               </a:rPr>
-              <a:t>stringTypeDec</a:t>
+              <a:t>stringTypeDecl</a:t>
+            </a:r>
+            <a:r>
+              <a:rPr lang="en-US" sz="1800">
+                <a:latin typeface="Consolas" panose="020B0609020204030204" pitchFamily="49" charset="0"/>
+              </a:rPr>
+              <a:t> .</a:t>
             </a:r>
             <a:br>
               <a:rPr lang="en-US" sz="1800" dirty="0">

</xml_diff>